<commit_message>
created support app and tools
</commit_message>
<xml_diff>
--- a/Resources/Notes.pptx
+++ b/Resources/Notes.pptx
@@ -270,7 +270,7 @@
           <a:p>
             <a:fld id="{D164E344-EFB8-4DA7-BDB6-6E8141447679}" type="datetimeFigureOut">
               <a:rPr lang="en-US" smtClean="0"/>
-              <a:t>6/20/2026</a:t>
+              <a:t>6/23/2026</a:t>
             </a:fld>
             <a:endParaRPr lang="en-US"/>
           </a:p>
@@ -468,7 +468,7 @@
           <a:p>
             <a:fld id="{D164E344-EFB8-4DA7-BDB6-6E8141447679}" type="datetimeFigureOut">
               <a:rPr lang="en-US" smtClean="0"/>
-              <a:t>6/20/2026</a:t>
+              <a:t>6/23/2026</a:t>
             </a:fld>
             <a:endParaRPr lang="en-US"/>
           </a:p>
@@ -676,7 +676,7 @@
           <a:p>
             <a:fld id="{D164E344-EFB8-4DA7-BDB6-6E8141447679}" type="datetimeFigureOut">
               <a:rPr lang="en-US" smtClean="0"/>
-              <a:t>6/20/2026</a:t>
+              <a:t>6/23/2026</a:t>
             </a:fld>
             <a:endParaRPr lang="en-US"/>
           </a:p>
@@ -874,7 +874,7 @@
           <a:p>
             <a:fld id="{D164E344-EFB8-4DA7-BDB6-6E8141447679}" type="datetimeFigureOut">
               <a:rPr lang="en-US" smtClean="0"/>
-              <a:t>6/20/2026</a:t>
+              <a:t>6/23/2026</a:t>
             </a:fld>
             <a:endParaRPr lang="en-US"/>
           </a:p>
@@ -1149,7 +1149,7 @@
           <a:p>
             <a:fld id="{D164E344-EFB8-4DA7-BDB6-6E8141447679}" type="datetimeFigureOut">
               <a:rPr lang="en-US" smtClean="0"/>
-              <a:t>6/20/2026</a:t>
+              <a:t>6/23/2026</a:t>
             </a:fld>
             <a:endParaRPr lang="en-US"/>
           </a:p>
@@ -1414,7 +1414,7 @@
           <a:p>
             <a:fld id="{D164E344-EFB8-4DA7-BDB6-6E8141447679}" type="datetimeFigureOut">
               <a:rPr lang="en-US" smtClean="0"/>
-              <a:t>6/20/2026</a:t>
+              <a:t>6/23/2026</a:t>
             </a:fld>
             <a:endParaRPr lang="en-US"/>
           </a:p>
@@ -1826,7 +1826,7 @@
           <a:p>
             <a:fld id="{D164E344-EFB8-4DA7-BDB6-6E8141447679}" type="datetimeFigureOut">
               <a:rPr lang="en-US" smtClean="0"/>
-              <a:t>6/20/2026</a:t>
+              <a:t>6/23/2026</a:t>
             </a:fld>
             <a:endParaRPr lang="en-US"/>
           </a:p>
@@ -1967,7 +1967,7 @@
           <a:p>
             <a:fld id="{D164E344-EFB8-4DA7-BDB6-6E8141447679}" type="datetimeFigureOut">
               <a:rPr lang="en-US" smtClean="0"/>
-              <a:t>6/20/2026</a:t>
+              <a:t>6/23/2026</a:t>
             </a:fld>
             <a:endParaRPr lang="en-US"/>
           </a:p>
@@ -2080,7 +2080,7 @@
           <a:p>
             <a:fld id="{D164E344-EFB8-4DA7-BDB6-6E8141447679}" type="datetimeFigureOut">
               <a:rPr lang="en-US" smtClean="0"/>
-              <a:t>6/20/2026</a:t>
+              <a:t>6/23/2026</a:t>
             </a:fld>
             <a:endParaRPr lang="en-US"/>
           </a:p>
@@ -2391,7 +2391,7 @@
           <a:p>
             <a:fld id="{D164E344-EFB8-4DA7-BDB6-6E8141447679}" type="datetimeFigureOut">
               <a:rPr lang="en-US" smtClean="0"/>
-              <a:t>6/20/2026</a:t>
+              <a:t>6/23/2026</a:t>
             </a:fld>
             <a:endParaRPr lang="en-US"/>
           </a:p>
@@ -2679,7 +2679,7 @@
           <a:p>
             <a:fld id="{D164E344-EFB8-4DA7-BDB6-6E8141447679}" type="datetimeFigureOut">
               <a:rPr lang="en-US" smtClean="0"/>
-              <a:t>6/20/2026</a:t>
+              <a:t>6/23/2026</a:t>
             </a:fld>
             <a:endParaRPr lang="en-US"/>
           </a:p>
@@ -2920,7 +2920,7 @@
           <a:p>
             <a:fld id="{D164E344-EFB8-4DA7-BDB6-6E8141447679}" type="datetimeFigureOut">
               <a:rPr lang="en-US" smtClean="0"/>
-              <a:t>6/20/2026</a:t>
+              <a:t>6/23/2026</a:t>
             </a:fld>
             <a:endParaRPr lang="en-US"/>
           </a:p>
@@ -3423,6 +3423,36 @@
           </p:txBody>
         </p:sp>
       </p:grpSp>
+      <p:pic>
+        <p:nvPicPr>
+          <p:cNvPr id="6" name="Picture 5">
+            <a:extLst>
+              <a:ext uri="{FF2B5EF4-FFF2-40B4-BE49-F238E27FC236}">
+                <a16:creationId xmlns:a16="http://schemas.microsoft.com/office/drawing/2014/main" id="{C9F1A8D1-C109-F5FD-6201-7F7FFA2B1562}"/>
+              </a:ext>
+            </a:extLst>
+          </p:cNvPr>
+          <p:cNvPicPr>
+            <a:picLocks noChangeAspect="1"/>
+          </p:cNvPicPr>
+          <p:nvPr/>
+        </p:nvPicPr>
+        <p:blipFill>
+          <a:blip r:embed="rId3"/>
+          <a:stretch>
+            <a:fillRect/>
+          </a:stretch>
+        </p:blipFill>
+        <p:spPr>
+          <a:xfrm>
+            <a:off x="467878" y="3429000"/>
+            <a:ext cx="7544853" cy="2619741"/>
+          </a:xfrm>
+          <a:prstGeom prst="rect">
+            <a:avLst/>
+          </a:prstGeom>
+        </p:spPr>
+      </p:pic>
     </p:spTree>
     <p:extLst>
       <p:ext uri="{BB962C8B-B14F-4D97-AF65-F5344CB8AC3E}">

</xml_diff>